<commit_message>
Add third team member (Anupria Gupta) to report and slides
Co-Authored-By: Claude Sonnet 5.5 <noreply@anthropic.com>
</commit_message>
<xml_diff>
--- a/docs/submission/MPFT_Presentation.pptx
+++ b/docs/submission/MPFT_Presentation.pptx
@@ -3650,7 +3650,7 @@
         <p:spPr>
           <a:xfrm>
             <a:off x="523875" y="4095750"/>
-            <a:ext cx="8096250" cy="714375"/>
+            <a:ext cx="8096250" cy="1035843"/>
           </a:xfrm>
           <a:prstGeom prst="rect">
             <a:avLst/>
@@ -3731,6 +3731,31 @@
                 <a:latin typeface="Arial"/>
               </a:rPr>
               <a:t> – PRN 1262242629</a:t>
+            </a:r>
+          </a:p>
+          <a:p>
+            <a:pPr algn="ctr">
+              <a:spcAft>
+                <a:spcPts val="200"/>
+              </a:spcAft>
+            </a:pPr>
+            <a:r>
+              <a:rPr sz="1700" b="1">
+                <a:solidFill>
+                  <a:srgbClr val="202020"/>
+                </a:solidFill>
+                <a:latin typeface="Arial"/>
+              </a:rPr>
+              <a:t>Anupria Gupta</a:t>
+            </a:r>
+            <a:r>
+              <a:rPr sz="1700" b="0">
+                <a:solidFill>
+                  <a:srgbClr val="202020"/>
+                </a:solidFill>
+                <a:latin typeface="Arial"/>
+              </a:rPr>
+              <a:t> – PRN 1262241349</a:t>
             </a:r>
           </a:p>
         </p:txBody>
@@ -3751,7 +3776,7 @@
         </p:nvSpPr>
         <p:spPr>
           <a:xfrm>
-            <a:off x="523875" y="5095875"/>
+            <a:off x="523875" y="5245875"/>
             <a:ext cx="8096250" cy="1143000"/>
           </a:xfrm>
           <a:prstGeom prst="rect">
@@ -8359,36 +8384,21 @@
 </file>
 
 <file path=ppt/slides/slide7.xml><?xml version="1.0" encoding="utf-8"?>
-<p:sld xmlns:a="http://schemas.openxmlformats.org/drawingml/2006/main" xmlns:r="http://schemas.openxmlformats.org/officeDocument/2006/relationships" xmlns:p="http://schemas.openxmlformats.org/presentationml/2006/main">
+<p:sld xmlns:a="http://schemas.openxmlformats.org/drawingml/2006/main" xmlns:p="http://schemas.openxmlformats.org/presentationml/2006/main" xmlns:r="http://schemas.openxmlformats.org/officeDocument/2006/relationships">
   <p:cSld>
-    <p:bg>
-      <p:bgPr>
-        <a:solidFill>
-          <a:srgbClr val="FFFFFF"/>
-        </a:solidFill>
-        <a:effectLst/>
-      </p:bgPr>
-    </p:bg>
     <p:spTree>
       <p:nvGrpSpPr>
         <p:cNvPr id="1" name=""/>
         <p:cNvGrpSpPr/>
         <p:nvPr/>
       </p:nvGrpSpPr>
-      <p:grpSpPr>
-        <a:xfrm>
-          <a:off x="0" y="0"/>
-          <a:ext cx="0" cy="0"/>
-          <a:chOff x="0" y="0"/>
-          <a:chExt cx="0" cy="0"/>
-        </a:xfrm>
-      </p:grpSpPr>
-      <p:sp>
-        <p:nvSpPr>
-          <p:cNvPr id="7" name="Rectangle 6">
+      <p:grpSpPr/>
+      <p:sp>
+        <p:nvSpPr>
+          <p:cNvPr id="8" name="Rectangle 7">
             <a:extLst>
               <a:ext uri="{FF2B5EF4-FFF2-40B4-BE49-F238E27FC236}">
-                <a16:creationId xmlns:a16="http://schemas.microsoft.com/office/drawing/2014/main" id="{D7465B80-86A3-4988-8BBF-D6C889F03087}"/>
+                <a16:creationId xmlns:a16="http://schemas.microsoft.com/office/drawing/2014/main" id="{3AB6F581-D019-4446-9B09-873266454C32}"/>
               </a:ext>
             </a:extLst>
           </p:cNvPr>
@@ -8445,7 +8455,7 @@
                 <a:ea typeface="Arial"/>
                 <a:cs typeface="Arial"/>
               </a:rPr>
-              <a:t>Conclusion and Contributions</a:t>
+              <a:t>Views and Scenarios</a:t>
             </a:r>
           </a:p>
         </p:txBody>
@@ -8455,7 +8465,7 @@
           <p:cNvPr id="2" name="Rectangle 1">
             <a:extLst>
               <a:ext uri="{FF2B5EF4-FFF2-40B4-BE49-F238E27FC236}">
-                <a16:creationId xmlns:a16="http://schemas.microsoft.com/office/drawing/2014/main" id="{D35C3C1D-1A36-4479-B48D-72AED4C5126A}"/>
+                <a16:creationId xmlns:a16="http://schemas.microsoft.com/office/drawing/2014/main" id="{D9B7B2C0-778B-420B-9AC8-791FED994D01}"/>
               </a:ext>
             </a:extLst>
           </p:cNvPr>
@@ -8522,7 +8532,7 @@
           <p:cNvPr id="3" name="Rectangle 2">
             <a:extLst>
               <a:ext uri="{FF2B5EF4-FFF2-40B4-BE49-F238E27FC236}">
-                <a16:creationId xmlns:a16="http://schemas.microsoft.com/office/drawing/2014/main" id="{83033241-AA33-4209-9B79-B06A3DA63F84}"/>
+                <a16:creationId xmlns:a16="http://schemas.microsoft.com/office/drawing/2014/main" id="{B5A4A980-7EF8-4344-9A96-EEAF374C7B47}"/>
               </a:ext>
             </a:extLst>
           </p:cNvPr>
@@ -8579,67 +8589,69 @@
                 <a:ea typeface="Arial"/>
                 <a:cs typeface="Arial"/>
               </a:rPr>
-              <a:t>30 seconds</a:t>
-            </a:r>
-          </a:p>
-        </p:txBody>
-      </p:sp>
-      <p:sp>
-        <p:nvSpPr>
-          <p:cNvPr id="8" name="Rounded Rectangle 7"/>
-          <p:cNvSpPr/>
-          <p:nvPr/>
-        </p:nvSpPr>
-        <p:spPr>
-          <a:xfrm>
-            <a:off x="521207" y="1280160"/>
-            <a:ext cx="3977639" cy="1280160"/>
-          </a:xfrm>
-          <a:prstGeom prst="roundRect">
-            <a:avLst>
-              <a:gd name="adj" fmla="val 4000"/>
-            </a:avLst>
-          </a:prstGeom>
-          <a:solidFill>
-            <a:srgbClr val="F1F4F6"/>
-          </a:solidFill>
-          <a:ln>
-            <a:noFill/>
-          </a:ln>
-          <a:effectLst/>
-        </p:spPr>
-        <p:style>
-          <a:lnRef idx="1">
-            <a:schemeClr val="accent1"/>
-          </a:lnRef>
-          <a:fillRef idx="3">
-            <a:schemeClr val="accent1"/>
-          </a:fillRef>
-          <a:effectRef idx="2">
-            <a:schemeClr val="accent1"/>
-          </a:effectRef>
-          <a:fontRef idx="minor">
-            <a:schemeClr val="lt1"/>
-          </a:fontRef>
-        </p:style>
-        <p:txBody>
-          <a:bodyPr rtlCol="0" anchor="ctr"/>
-          <a:lstStyle/>
-          <a:p>
-            <a:pPr algn="ctr"/>
-          </a:p>
-        </p:txBody>
-      </p:sp>
-      <p:sp>
-        <p:nvSpPr>
-          <p:cNvPr id="9" name="TextBox 8"/>
+              <a:t>35 seconds</a:t>
+            </a:r>
+          </a:p>
+        </p:txBody>
+      </p:sp>
+      <p:pic>
+        <p:nvPicPr>
+          <p:cNvPr id="9" name="Picture 8" descr="scn_sender.png"/>
+          <p:cNvPicPr>
+            <a:picLocks noChangeAspect="1"/>
+          </p:cNvPicPr>
+          <p:nvPr/>
+        </p:nvPicPr>
+        <p:blipFill>
+          <a:blip r:embed="rId2"/>
+          <a:stretch>
+            <a:fillRect/>
+          </a:stretch>
+        </p:blipFill>
+        <p:spPr>
+          <a:xfrm>
+            <a:off x="523875" y="1250000"/>
+            <a:ext cx="4000000" cy="3032258"/>
+          </a:xfrm>
+          <a:prstGeom prst="rect">
+            <a:avLst/>
+          </a:prstGeom>
+        </p:spPr>
+      </p:pic>
+      <p:pic>
+        <p:nvPicPr>
+          <p:cNvPr id="10" name="Picture 9" descr="scn_receiver.png"/>
+          <p:cNvPicPr>
+            <a:picLocks noChangeAspect="1"/>
+          </p:cNvPicPr>
+          <p:nvPr/>
+        </p:nvPicPr>
+        <p:blipFill>
+          <a:blip r:embed="rId3"/>
+          <a:stretch>
+            <a:fillRect/>
+          </a:stretch>
+        </p:blipFill>
+        <p:spPr>
+          <a:xfrm>
+            <a:off x="4673875" y="1250000"/>
+            <a:ext cx="4000000" cy="3032258"/>
+          </a:xfrm>
+          <a:prstGeom prst="rect">
+            <a:avLst/>
+          </a:prstGeom>
+        </p:spPr>
+      </p:pic>
+      <p:sp>
+        <p:nvSpPr>
+          <p:cNvPr id="11" name="TextBox 10"/>
           <p:cNvSpPr txBox="1"/>
           <p:nvPr/>
         </p:nvSpPr>
         <p:spPr>
           <a:xfrm>
-            <a:off x="704088" y="1389888"/>
-            <a:ext cx="3611879" cy="274320"/>
+            <a:off x="523875" y="4322258"/>
+            <a:ext cx="4000000" cy="300000"/>
           </a:xfrm>
           <a:prstGeom prst="rect">
             <a:avLst/>
@@ -8647,38 +8659,32 @@
           <a:noFill/>
         </p:spPr>
         <p:txBody>
-          <a:bodyPr wrap="square" lIns="0" rIns="0" tIns="0" bIns="0" anchor="t">
+          <a:bodyPr wrap="square">
             <a:spAutoFit/>
           </a:bodyPr>
           <a:lstStyle/>
           <a:p>
-            <a:pPr algn="l">
-              <a:spcAft>
-                <a:spcPts val="400"/>
-              </a:spcAft>
-            </a:pPr>
             <a:r>
               <a:rPr sz="1100" b="1">
                 <a:solidFill>
-                  <a:srgbClr val="1B6B73"/>
-                </a:solidFill>
-                <a:latin typeface="Arial"/>
-              </a:rPr>
-              <a:t>OUTCOME</a:t>
-            </a:r>
-          </a:p>
-        </p:txBody>
-      </p:sp>
-      <p:sp>
-        <p:nvSpPr>
-          <p:cNvPr id="10" name="TextBox 9"/>
+                  <a:srgbClr val="16324F"/>
+                </a:solidFill>
+              </a:rPr>
+              <a:t>Sender: Delivered, send another</a:t>
+            </a:r>
+          </a:p>
+        </p:txBody>
+      </p:sp>
+      <p:sp>
+        <p:nvSpPr>
+          <p:cNvPr id="12" name="TextBox 11"/>
           <p:cNvSpPr txBox="1"/>
           <p:nvPr/>
         </p:nvSpPr>
         <p:spPr>
           <a:xfrm>
-            <a:off x="704088" y="1664207"/>
-            <a:ext cx="3611879" cy="822959"/>
+            <a:off x="4673875" y="4322258"/>
+            <a:ext cx="4000000" cy="300000"/>
           </a:xfrm>
           <a:prstGeom prst="rect">
             <a:avLst/>
@@ -8686,84 +8692,32 @@
           <a:noFill/>
         </p:spPr>
         <p:txBody>
-          <a:bodyPr wrap="square" lIns="0" rIns="0" tIns="0" bIns="0" anchor="t">
+          <a:bodyPr wrap="square">
             <a:spAutoFit/>
           </a:bodyPr>
           <a:lstStyle/>
           <a:p>
-            <a:pPr algn="l">
-              <a:spcAft>
-                <a:spcPts val="0"/>
-              </a:spcAft>
-            </a:pPr>
-            <a:r>
-              <a:rPr sz="1400" b="0">
-                <a:solidFill>
-                  <a:srgbClr val="202020"/>
-                </a:solidFill>
-                <a:latin typeface="Arial"/>
-              </a:rPr>
-              <a:t>Working multipath transfer with chunk and file verification, failure recovery and resume</a:t>
-            </a:r>
-          </a:p>
-        </p:txBody>
-      </p:sp>
-      <p:sp>
-        <p:nvSpPr>
-          <p:cNvPr id="11" name="Rounded Rectangle 10"/>
-          <p:cNvSpPr/>
-          <p:nvPr/>
-        </p:nvSpPr>
-        <p:spPr>
-          <a:xfrm>
-            <a:off x="4636008" y="1280160"/>
-            <a:ext cx="3977639" cy="1280160"/>
-          </a:xfrm>
-          <a:prstGeom prst="roundRect">
-            <a:avLst>
-              <a:gd name="adj" fmla="val 4000"/>
-            </a:avLst>
-          </a:prstGeom>
-          <a:solidFill>
-            <a:srgbClr val="F1F4F6"/>
-          </a:solidFill>
-          <a:ln>
-            <a:noFill/>
-          </a:ln>
-          <a:effectLst/>
-        </p:spPr>
-        <p:style>
-          <a:lnRef idx="1">
-            <a:schemeClr val="accent1"/>
-          </a:lnRef>
-          <a:fillRef idx="3">
-            <a:schemeClr val="accent1"/>
-          </a:fillRef>
-          <a:effectRef idx="2">
-            <a:schemeClr val="accent1"/>
-          </a:effectRef>
-          <a:fontRef idx="minor">
-            <a:schemeClr val="lt1"/>
-          </a:fontRef>
-        </p:style>
-        <p:txBody>
-          <a:bodyPr rtlCol="0" anchor="ctr"/>
-          <a:lstStyle/>
-          <a:p>
-            <a:pPr algn="ctr"/>
-          </a:p>
-        </p:txBody>
-      </p:sp>
-      <p:sp>
-        <p:nvSpPr>
-          <p:cNvPr id="12" name="TextBox 11"/>
+            <a:r>
+              <a:rPr sz="1100" b="1">
+                <a:solidFill>
+                  <a:srgbClr val="16324F"/>
+                </a:solidFill>
+              </a:rPr>
+              <a:t>Receiver: verified, Download</a:t>
+            </a:r>
+          </a:p>
+        </p:txBody>
+      </p:sp>
+      <p:sp>
+        <p:nvSpPr>
+          <p:cNvPr id="13" name="TextBox 12"/>
           <p:cNvSpPr txBox="1"/>
           <p:nvPr/>
         </p:nvSpPr>
         <p:spPr>
           <a:xfrm>
-            <a:off x="4818888" y="1389888"/>
-            <a:ext cx="3611879" cy="274320"/>
+            <a:off x="523875" y="4652258"/>
+            <a:ext cx="8150000" cy="300000"/>
           </a:xfrm>
           <a:prstGeom prst="rect">
             <a:avLst/>
@@ -8771,38 +8725,32 @@
           <a:noFill/>
         </p:spPr>
         <p:txBody>
-          <a:bodyPr wrap="square" lIns="0" rIns="0" tIns="0" bIns="0" anchor="t">
+          <a:bodyPr wrap="square">
             <a:spAutoFit/>
           </a:bodyPr>
           <a:lstStyle/>
           <a:p>
-            <a:pPr algn="l">
-              <a:spcAft>
-                <a:spcPts val="400"/>
-              </a:spcAft>
-            </a:pPr>
-            <a:r>
-              <a:rPr sz="1100" b="1">
-                <a:solidFill>
-                  <a:srgbClr val="1B6B73"/>
-                </a:solidFill>
-                <a:latin typeface="Arial"/>
-              </a:rPr>
-              <a:t>APPLICATION</a:t>
-            </a:r>
-          </a:p>
-        </p:txBody>
-      </p:sp>
-      <p:sp>
-        <p:nvSpPr>
-          <p:cNvPr id="13" name="TextBox 12"/>
+            <a:r>
+              <a:rPr sz="1100" b="0">
+                <a:solidFill>
+                  <a:srgbClr val="16324F"/>
+                </a:solidFill>
+              </a:rPr>
+              <a:t>Eight scenarios: clean, slow, asymmetric, lossy, heavy loss, path failure, path flap, total failure (nothing saved, no download).</a:t>
+            </a:r>
+          </a:p>
+        </p:txBody>
+      </p:sp>
+      <p:sp>
+        <p:nvSpPr>
+          <p:cNvPr id="14" name="TextBox 13"/>
           <p:cNvSpPr txBox="1"/>
           <p:nvPr/>
         </p:nvSpPr>
         <p:spPr>
           <a:xfrm>
-            <a:off x="4818888" y="1664207"/>
-            <a:ext cx="3611879" cy="822959"/>
+            <a:off x="523875" y="5122258"/>
+            <a:ext cx="8150000" cy="300000"/>
           </a:xfrm>
           <a:prstGeom prst="rect">
             <a:avLst/>
@@ -8810,571 +8758,23 @@
           <a:noFill/>
         </p:spPr>
         <p:txBody>
-          <a:bodyPr wrap="square" lIns="0" rIns="0" tIns="0" bIns="0" anchor="t">
+          <a:bodyPr wrap="square">
             <a:spAutoFit/>
           </a:bodyPr>
           <a:lstStyle/>
           <a:p>
-            <a:pPr algn="l">
-              <a:spcAft>
-                <a:spcPts val="0"/>
-              </a:spcAft>
-            </a:pPr>
-            <a:r>
-              <a:rPr sz="1400" b="0">
-                <a:solidFill>
-                  <a:srgbClr val="202020"/>
-                </a:solidFill>
-                <a:latin typeface="Arial"/>
-              </a:rPr>
-              <a:t>Large files over several links (Wi-Fi plus Ethernet, LAN plus VPN)</a:t>
-            </a:r>
-          </a:p>
-        </p:txBody>
-      </p:sp>
-      <p:sp>
-        <p:nvSpPr>
-          <p:cNvPr id="14" name="Rounded Rectangle 13"/>
-          <p:cNvSpPr/>
-          <p:nvPr/>
-        </p:nvSpPr>
-        <p:spPr>
-          <a:xfrm>
-            <a:off x="521207" y="2651760"/>
-            <a:ext cx="3977639" cy="1280160"/>
-          </a:xfrm>
-          <a:prstGeom prst="roundRect">
-            <a:avLst>
-              <a:gd name="adj" fmla="val 4000"/>
-            </a:avLst>
-          </a:prstGeom>
-          <a:solidFill>
-            <a:srgbClr val="F1F4F6"/>
-          </a:solidFill>
-          <a:ln>
-            <a:noFill/>
-          </a:ln>
-          <a:effectLst/>
-        </p:spPr>
-        <p:style>
-          <a:lnRef idx="1">
-            <a:schemeClr val="accent1"/>
-          </a:lnRef>
-          <a:fillRef idx="3">
-            <a:schemeClr val="accent1"/>
-          </a:fillRef>
-          <a:effectRef idx="2">
-            <a:schemeClr val="accent1"/>
-          </a:effectRef>
-          <a:fontRef idx="minor">
-            <a:schemeClr val="lt1"/>
-          </a:fontRef>
-        </p:style>
-        <p:txBody>
-          <a:bodyPr rtlCol="0" anchor="ctr"/>
-          <a:lstStyle/>
-          <a:p>
-            <a:pPr algn="ctr"/>
-          </a:p>
-        </p:txBody>
-      </p:sp>
-      <p:sp>
-        <p:nvSpPr>
-          <p:cNvPr id="15" name="TextBox 14"/>
-          <p:cNvSpPr txBox="1"/>
-          <p:nvPr/>
-        </p:nvSpPr>
-        <p:spPr>
-          <a:xfrm>
-            <a:off x="704088" y="2761488"/>
-            <a:ext cx="3611879" cy="274320"/>
-          </a:xfrm>
-          <a:prstGeom prst="rect">
-            <a:avLst/>
-          </a:prstGeom>
-          <a:noFill/>
-        </p:spPr>
-        <p:txBody>
-          <a:bodyPr wrap="square" lIns="0" rIns="0" tIns="0" bIns="0" anchor="t">
-            <a:spAutoFit/>
-          </a:bodyPr>
-          <a:lstStyle/>
-          <a:p>
-            <a:pPr algn="l">
-              <a:spcAft>
-                <a:spcPts val="400"/>
-              </a:spcAft>
-            </a:pPr>
-            <a:r>
-              <a:rPr sz="1100" b="1">
-                <a:solidFill>
-                  <a:srgbClr val="1B6B73"/>
-                </a:solidFill>
-                <a:latin typeface="Arial"/>
-              </a:rPr>
-              <a:t>LIMITATION</a:t>
-            </a:r>
-          </a:p>
-        </p:txBody>
-      </p:sp>
-      <p:sp>
-        <p:nvSpPr>
-          <p:cNvPr id="16" name="TextBox 15"/>
-          <p:cNvSpPr txBox="1"/>
-          <p:nvPr/>
-        </p:nvSpPr>
-        <p:spPr>
-          <a:xfrm>
-            <a:off x="704088" y="3035808"/>
-            <a:ext cx="3611879" cy="822959"/>
-          </a:xfrm>
-          <a:prstGeom prst="rect">
-            <a:avLst/>
-          </a:prstGeom>
-          <a:noFill/>
-        </p:spPr>
-        <p:txBody>
-          <a:bodyPr wrap="square" lIns="0" rIns="0" tIns="0" bIns="0" anchor="t">
-            <a:spAutoFit/>
-          </a:bodyPr>
-          <a:lstStyle/>
-          <a:p>
-            <a:pPr algn="l">
-              <a:spcAft>
-                <a:spcPts val="0"/>
-              </a:spcAft>
-            </a:pPr>
-            <a:r>
-              <a:rPr sz="1400" b="0">
-                <a:solidFill>
-                  <a:srgbClr val="202020"/>
-                </a:solidFill>
-                <a:latin typeface="Arial"/>
-              </a:rPr>
-              <a:t>One chunk in flight per path; tested on emulated paths on one machine only</a:t>
-            </a:r>
-          </a:p>
-        </p:txBody>
-      </p:sp>
-      <p:sp>
-        <p:nvSpPr>
-          <p:cNvPr id="17" name="Rounded Rectangle 16"/>
-          <p:cNvSpPr/>
-          <p:nvPr/>
-        </p:nvSpPr>
-        <p:spPr>
-          <a:xfrm>
-            <a:off x="4636008" y="2651760"/>
-            <a:ext cx="3977639" cy="1280160"/>
-          </a:xfrm>
-          <a:prstGeom prst="roundRect">
-            <a:avLst>
-              <a:gd name="adj" fmla="val 4000"/>
-            </a:avLst>
-          </a:prstGeom>
-          <a:solidFill>
-            <a:srgbClr val="F1F4F6"/>
-          </a:solidFill>
-          <a:ln>
-            <a:noFill/>
-          </a:ln>
-          <a:effectLst/>
-        </p:spPr>
-        <p:style>
-          <a:lnRef idx="1">
-            <a:schemeClr val="accent1"/>
-          </a:lnRef>
-          <a:fillRef idx="3">
-            <a:schemeClr val="accent1"/>
-          </a:fillRef>
-          <a:effectRef idx="2">
-            <a:schemeClr val="accent1"/>
-          </a:effectRef>
-          <a:fontRef idx="minor">
-            <a:schemeClr val="lt1"/>
-          </a:fontRef>
-        </p:style>
-        <p:txBody>
-          <a:bodyPr rtlCol="0" anchor="ctr"/>
-          <a:lstStyle/>
-          <a:p>
-            <a:pPr algn="ctr"/>
-          </a:p>
-        </p:txBody>
-      </p:sp>
-      <p:sp>
-        <p:nvSpPr>
-          <p:cNvPr id="18" name="TextBox 17"/>
-          <p:cNvSpPr txBox="1"/>
-          <p:nvPr/>
-        </p:nvSpPr>
-        <p:spPr>
-          <a:xfrm>
-            <a:off x="4818888" y="2761488"/>
-            <a:ext cx="3611879" cy="274320"/>
-          </a:xfrm>
-          <a:prstGeom prst="rect">
-            <a:avLst/>
-          </a:prstGeom>
-          <a:noFill/>
-        </p:spPr>
-        <p:txBody>
-          <a:bodyPr wrap="square" lIns="0" rIns="0" tIns="0" bIns="0" anchor="t">
-            <a:spAutoFit/>
-          </a:bodyPr>
-          <a:lstStyle/>
-          <a:p>
-            <a:pPr algn="l">
-              <a:spcAft>
-                <a:spcPts val="400"/>
-              </a:spcAft>
-            </a:pPr>
-            <a:r>
-              <a:rPr sz="1100" b="1">
-                <a:solidFill>
-                  <a:srgbClr val="1B6B73"/>
-                </a:solidFill>
-                <a:latin typeface="Arial"/>
-              </a:rPr>
-              <a:t>FUTURE SCOPE</a:t>
-            </a:r>
-          </a:p>
-        </p:txBody>
-      </p:sp>
-      <p:sp>
-        <p:nvSpPr>
-          <p:cNvPr id="19" name="TextBox 18"/>
-          <p:cNvSpPr txBox="1"/>
-          <p:nvPr/>
-        </p:nvSpPr>
-        <p:spPr>
-          <a:xfrm>
-            <a:off x="4818888" y="3035808"/>
-            <a:ext cx="3611879" cy="822959"/>
-          </a:xfrm>
-          <a:prstGeom prst="rect">
-            <a:avLst/>
-          </a:prstGeom>
-          <a:noFill/>
-        </p:spPr>
-        <p:txBody>
-          <a:bodyPr wrap="square" lIns="0" rIns="0" tIns="0" bIns="0" anchor="t">
-            <a:spAutoFit/>
-          </a:bodyPr>
-          <a:lstStyle/>
-          <a:p>
-            <a:pPr algn="l">
-              <a:spcAft>
-                <a:spcPts val="0"/>
-              </a:spcAft>
-            </a:pPr>
-            <a:r>
-              <a:rPr sz="1400" b="0">
-                <a:solidFill>
-                  <a:srgbClr val="202020"/>
-                </a:solidFill>
-                <a:latin typeface="Arial"/>
-              </a:rPr>
-              <a:t>Sliding window per path; real two-machine test with Wireshark captures</a:t>
-            </a:r>
-          </a:p>
-        </p:txBody>
-      </p:sp>
-      <p:sp>
-        <p:nvSpPr>
-          <p:cNvPr id="20" name="Rounded Rectangle 19"/>
-          <p:cNvSpPr/>
-          <p:nvPr/>
-        </p:nvSpPr>
-        <p:spPr>
-          <a:xfrm>
-            <a:off x="521207" y="4114800"/>
-            <a:ext cx="8092440" cy="1280160"/>
-          </a:xfrm>
-          <a:prstGeom prst="roundRect">
-            <a:avLst>
-              <a:gd name="adj" fmla="val 4000"/>
-            </a:avLst>
-          </a:prstGeom>
-          <a:solidFill>
-            <a:srgbClr val="F1F4F6"/>
-          </a:solidFill>
-          <a:ln>
-            <a:noFill/>
-          </a:ln>
-          <a:effectLst/>
-        </p:spPr>
-        <p:style>
-          <a:lnRef idx="1">
-            <a:schemeClr val="accent1"/>
-          </a:lnRef>
-          <a:fillRef idx="3">
-            <a:schemeClr val="accent1"/>
-          </a:fillRef>
-          <a:effectRef idx="2">
-            <a:schemeClr val="accent1"/>
-          </a:effectRef>
-          <a:fontRef idx="minor">
-            <a:schemeClr val="lt1"/>
-          </a:fontRef>
-        </p:style>
-        <p:txBody>
-          <a:bodyPr rtlCol="0" anchor="ctr"/>
-          <a:lstStyle/>
-          <a:p>
-            <a:pPr algn="ctr"/>
-          </a:p>
-        </p:txBody>
-      </p:sp>
-      <p:sp>
-        <p:nvSpPr>
-          <p:cNvPr id="21" name="TextBox 20"/>
-          <p:cNvSpPr txBox="1"/>
-          <p:nvPr/>
-        </p:nvSpPr>
-        <p:spPr>
-          <a:xfrm>
-            <a:off x="731520" y="4206240"/>
-            <a:ext cx="7680960" cy="274320"/>
-          </a:xfrm>
-          <a:prstGeom prst="rect">
-            <a:avLst/>
-          </a:prstGeom>
-          <a:noFill/>
-        </p:spPr>
-        <p:txBody>
-          <a:bodyPr wrap="square" lIns="0" rIns="0" tIns="0" bIns="0" anchor="t">
-            <a:spAutoFit/>
-          </a:bodyPr>
-          <a:lstStyle/>
-          <a:p>
-            <a:pPr algn="l">
-              <a:spcAft>
-                <a:spcPts val="400"/>
-              </a:spcAft>
-            </a:pPr>
-            <a:r>
-              <a:rPr sz="1100" b="1">
-                <a:solidFill>
-                  <a:srgbClr val="1B6B73"/>
-                </a:solidFill>
-                <a:latin typeface="Arial"/>
-              </a:rPr>
-              <a:t>TEAM CONTRIBUTIONS</a:t>
-            </a:r>
-          </a:p>
-        </p:txBody>
-      </p:sp>
-      <p:sp>
-        <p:nvSpPr>
-          <p:cNvPr id="22" name="TextBox 21"/>
-          <p:cNvSpPr txBox="1"/>
-          <p:nvPr/>
-        </p:nvSpPr>
-        <p:spPr>
-          <a:xfrm>
-            <a:off x="731520" y="4526280"/>
-            <a:ext cx="3840480" cy="822960"/>
-          </a:xfrm>
-          <a:prstGeom prst="rect">
-            <a:avLst/>
-          </a:prstGeom>
-          <a:noFill/>
-        </p:spPr>
-        <p:txBody>
-          <a:bodyPr wrap="square" lIns="0" rIns="0" tIns="0" bIns="0" anchor="t">
-            <a:spAutoFit/>
-          </a:bodyPr>
-          <a:lstStyle/>
-          <a:p>
-            <a:pPr algn="l">
-              <a:spcAft>
-                <a:spcPts val="200"/>
-              </a:spcAft>
-            </a:pPr>
-            <a:r>
-              <a:rPr sz="1300" b="1">
-                <a:solidFill>
-                  <a:srgbClr val="202020"/>
-                </a:solidFill>
-                <a:latin typeface="Arial"/>
-              </a:rPr>
-              <a:t>Saksham Singh Sisodiya</a:t>
-            </a:r>
-          </a:p>
-          <a:p>
-            <a:pPr algn="l">
-              <a:spcAft>
-                <a:spcPts val="200"/>
-              </a:spcAft>
-            </a:pPr>
-            <a:r>
-              <a:rPr sz="1300" b="0">
-                <a:solidFill>
-                  <a:srgbClr val="202020"/>
-                </a:solidFill>
-                <a:latin typeface="Arial"/>
-              </a:rPr>
-              <a:t>Protocol, sender, receiver, resume, web UI</a:t>
-            </a:r>
-          </a:p>
-        </p:txBody>
-      </p:sp>
-      <p:sp>
-        <p:nvSpPr>
-          <p:cNvPr id="23" name="TextBox 22"/>
-          <p:cNvSpPr txBox="1"/>
-          <p:nvPr/>
-        </p:nvSpPr>
-        <p:spPr>
-          <a:xfrm>
-            <a:off x="4754880" y="4526280"/>
-            <a:ext cx="3749039" cy="822960"/>
-          </a:xfrm>
-          <a:prstGeom prst="rect">
-            <a:avLst/>
-          </a:prstGeom>
-          <a:noFill/>
-        </p:spPr>
-        <p:txBody>
-          <a:bodyPr wrap="square" lIns="0" rIns="0" tIns="0" bIns="0" anchor="t">
-            <a:spAutoFit/>
-          </a:bodyPr>
-          <a:lstStyle/>
-          <a:p>
-            <a:pPr algn="l">
-              <a:spcAft>
-                <a:spcPts val="200"/>
-              </a:spcAft>
-            </a:pPr>
-            <a:r>
-              <a:rPr sz="1300" b="1">
-                <a:solidFill>
-                  <a:srgbClr val="202020"/>
-                </a:solidFill>
-                <a:latin typeface="Arial"/>
-              </a:rPr>
-              <a:t>Parth Dande</a:t>
-            </a:r>
-          </a:p>
-          <a:p>
-            <a:pPr algn="l">
-              <a:spcAft>
-                <a:spcPts val="200"/>
-              </a:spcAft>
-            </a:pPr>
-            <a:r>
-              <a:rPr sz="1300" b="0">
-                <a:solidFill>
-                  <a:srgbClr val="202020"/>
-                </a:solidFill>
-                <a:latin typeface="Arial"/>
-              </a:rPr>
-              <a:t>Emulator, experiments, Wireshark dissector, test report</a:t>
-            </a:r>
-          </a:p>
-        </p:txBody>
-      </p:sp>
-      <p:sp>
-        <p:nvSpPr>
-          <p:cNvPr id="24" name="Rounded Rectangle 23"/>
-          <p:cNvSpPr/>
-          <p:nvPr/>
-        </p:nvSpPr>
-        <p:spPr>
-          <a:xfrm>
-            <a:off x="521207" y="5532120"/>
-            <a:ext cx="8092440" cy="640080"/>
-          </a:xfrm>
-          <a:prstGeom prst="roundRect">
-            <a:avLst>
-              <a:gd name="adj" fmla="val 4000"/>
-            </a:avLst>
-          </a:prstGeom>
-          <a:solidFill>
-            <a:srgbClr val="F1F4F6"/>
-          </a:solidFill>
-          <a:ln>
-            <a:noFill/>
-          </a:ln>
-          <a:effectLst/>
-        </p:spPr>
-        <p:style>
-          <a:lnRef idx="1">
-            <a:schemeClr val="accent1"/>
-          </a:lnRef>
-          <a:fillRef idx="3">
-            <a:schemeClr val="accent1"/>
-          </a:fillRef>
-          <a:effectRef idx="2">
-            <a:schemeClr val="accent1"/>
-          </a:effectRef>
-          <a:fontRef idx="minor">
-            <a:schemeClr val="lt1"/>
-          </a:fontRef>
-        </p:style>
-        <p:txBody>
-          <a:bodyPr rtlCol="0" anchor="ctr"/>
-          <a:lstStyle/>
-          <a:p>
-            <a:pPr algn="ctr"/>
-          </a:p>
-        </p:txBody>
-      </p:sp>
-      <p:sp>
-        <p:nvSpPr>
-          <p:cNvPr id="25" name="TextBox 24"/>
-          <p:cNvSpPr txBox="1"/>
-          <p:nvPr/>
-        </p:nvSpPr>
-        <p:spPr>
-          <a:xfrm>
-            <a:off x="731520" y="5577840"/>
-            <a:ext cx="7680960" cy="548640"/>
-          </a:xfrm>
-          <a:prstGeom prst="rect">
-            <a:avLst/>
-          </a:prstGeom>
-          <a:noFill/>
-        </p:spPr>
-        <p:txBody>
-          <a:bodyPr wrap="square" lIns="0" rIns="0" tIns="0" bIns="0" anchor="ctr">
-            <a:spAutoFit/>
-          </a:bodyPr>
-          <a:lstStyle/>
-          <a:p>
-            <a:pPr algn="l">
-              <a:spcAft>
-                <a:spcPts val="400"/>
-              </a:spcAft>
-            </a:pPr>
-            <a:r>
-              <a:rPr sz="1250" b="1">
-                <a:solidFill>
-                  <a:srgbClr val="202020"/>
-                </a:solidFill>
-                <a:latin typeface="Arial"/>
-              </a:rPr>
-              <a:t>AI use:</a:t>
-            </a:r>
-            <a:r>
-              <a:rPr sz="1250" b="0">
-                <a:solidFill>
-                  <a:srgbClr val="202020"/>
-                </a:solidFill>
-                <a:latin typeface="Arial"/>
-              </a:rPr>
-              <a:t> Claude Code helped write code, tests and documents; all results come from running the code.</a:t>
+            <a:r>
+              <a:rPr sz="1100" b="0">
+                <a:solidFill>
+                  <a:srgbClr val="16324F"/>
+                </a:solidFill>
+              </a:rPr>
+              <a:t>Graphs now use real time: throughput from chunk completions, millisecond axis under 2 s.</a:t>
             </a:r>
           </a:p>
         </p:txBody>
       </p:sp>
     </p:spTree>
-    <p:extLst>
-      <p:ext uri="{BB962C8B-B14F-4D97-AF65-F5344CB8AC3E}">
-        <p14:creationId xmlns:p14="http://schemas.microsoft.com/office/powerpoint/2010/main" val="2125721340"/>
-      </p:ext>
-    </p:extLst>
   </p:cSld>
   <p:clrMapOvr>
     <a:masterClrMapping/>
@@ -9409,10 +8809,10 @@
       </p:grpSpPr>
       <p:sp>
         <p:nvSpPr>
-          <p:cNvPr id="6" name="Rectangle 5">
+          <p:cNvPr id="7" name="Rectangle 6">
             <a:extLst>
               <a:ext uri="{FF2B5EF4-FFF2-40B4-BE49-F238E27FC236}">
-                <a16:creationId xmlns:a16="http://schemas.microsoft.com/office/drawing/2014/main" id="{2B87E46F-E649-4EC2-BE15-E3DC1B512D09}"/>
+                <a16:creationId xmlns:a16="http://schemas.microsoft.com/office/drawing/2014/main" id="{D7465B80-86A3-4988-8BBF-D6C889F03087}"/>
               </a:ext>
             </a:extLst>
           </p:cNvPr>
@@ -9461,7 +8861,7 @@
               </a:defRPr>
             </a:pPr>
             <a:r>
-              <a:rPr sz="2550" b="1">
+              <a:rPr sz="2550" b="1" dirty="0">
                 <a:solidFill>
                   <a:srgbClr val="20375C"/>
                 </a:solidFill>
@@ -9469,7 +8869,7 @@
                 <a:ea typeface="Arial"/>
                 <a:cs typeface="Arial"/>
               </a:rPr>
-              <a:t>References</a:t>
+              <a:t>Conclusion and Contributions</a:t>
             </a:r>
           </a:p>
         </p:txBody>
@@ -9479,7 +8879,7 @@
           <p:cNvPr id="2" name="Rectangle 1">
             <a:extLst>
               <a:ext uri="{FF2B5EF4-FFF2-40B4-BE49-F238E27FC236}">
-                <a16:creationId xmlns:a16="http://schemas.microsoft.com/office/drawing/2014/main" id="{D28BC680-DAE1-4C4A-B29D-BFCE9D74EB15}"/>
+                <a16:creationId xmlns:a16="http://schemas.microsoft.com/office/drawing/2014/main" id="{D35C3C1D-1A36-4479-B48D-72AED4C5126A}"/>
               </a:ext>
             </a:extLst>
           </p:cNvPr>
@@ -9546,7 +8946,7 @@
           <p:cNvPr id="3" name="Rectangle 2">
             <a:extLst>
               <a:ext uri="{FF2B5EF4-FFF2-40B4-BE49-F238E27FC236}">
-                <a16:creationId xmlns:a16="http://schemas.microsoft.com/office/drawing/2014/main" id="{52937739-9035-4330-B6E1-0CD991043B34}"/>
+                <a16:creationId xmlns:a16="http://schemas.microsoft.com/office/drawing/2014/main" id="{83033241-AA33-4209-9B79-B06A3DA63F84}"/>
               </a:ext>
             </a:extLst>
           </p:cNvPr>
@@ -9603,21 +9003,21 @@
                 <a:ea typeface="Arial"/>
                 <a:cs typeface="Arial"/>
               </a:rPr>
-              <a:t>Backup slide</a:t>
-            </a:r>
-          </a:p>
-        </p:txBody>
-      </p:sp>
-      <p:sp>
-        <p:nvSpPr>
-          <p:cNvPr id="7" name="Rounded Rectangle 6"/>
+              <a:t>30 seconds</a:t>
+            </a:r>
+          </a:p>
+        </p:txBody>
+      </p:sp>
+      <p:sp>
+        <p:nvSpPr>
+          <p:cNvPr id="8" name="Rounded Rectangle 7"/>
           <p:cNvSpPr/>
           <p:nvPr/>
         </p:nvSpPr>
         <p:spPr>
           <a:xfrm>
-            <a:off x="521207" y="1325880"/>
-            <a:ext cx="8092440" cy="3566160"/>
+            <a:off x="521207" y="1280160"/>
+            <a:ext cx="3977639" cy="1280160"/>
           </a:xfrm>
           <a:prstGeom prst="roundRect">
             <a:avLst>
@@ -9656,14 +9056,14 @@
       </p:sp>
       <p:sp>
         <p:nvSpPr>
-          <p:cNvPr id="8" name="TextBox 7"/>
+          <p:cNvPr id="9" name="TextBox 8"/>
           <p:cNvSpPr txBox="1"/>
           <p:nvPr/>
         </p:nvSpPr>
         <p:spPr>
           <a:xfrm>
-            <a:off x="777240" y="1554480"/>
-            <a:ext cx="7589520" cy="3200400"/>
+            <a:off x="704088" y="1389888"/>
+            <a:ext cx="3611879" cy="274320"/>
           </a:xfrm>
           <a:prstGeom prst="rect">
             <a:avLst/>
@@ -9678,140 +9078,31 @@
           <a:p>
             <a:pPr algn="l">
               <a:spcAft>
-                <a:spcPts val="1000"/>
-              </a:spcAft>
-            </a:pPr>
-            <a:r>
-              <a:rPr sz="1500" b="0">
-                <a:solidFill>
-                  <a:srgbClr val="202020"/>
-                </a:solidFill>
-                <a:latin typeface="Arial"/>
-              </a:rPr>
-              <a:t>[1]</a:t>
-            </a:r>
-            <a:r>
-              <a:rPr sz="1500" b="0">
-                <a:solidFill>
-                  <a:srgbClr val="202020"/>
-                </a:solidFill>
-                <a:latin typeface="Arial"/>
-              </a:rPr>
-              <a:t>  J. Eddy, “Transmission Control Protocol (TCP),” RFC 9293, IETF, 2022.</a:t>
-            </a:r>
-          </a:p>
-          <a:p>
-            <a:pPr algn="l">
-              <a:spcAft>
-                <a:spcPts val="1000"/>
-              </a:spcAft>
-            </a:pPr>
-            <a:r>
-              <a:rPr sz="1500" b="0">
-                <a:solidFill>
-                  <a:srgbClr val="202020"/>
-                </a:solidFill>
-                <a:latin typeface="Arial"/>
-              </a:rPr>
-              <a:t>[2]</a:t>
-            </a:r>
-            <a:r>
-              <a:rPr sz="1500" b="0">
-                <a:solidFill>
-                  <a:srgbClr val="202020"/>
-                </a:solidFill>
-                <a:latin typeface="Arial"/>
-              </a:rPr>
-              <a:t>  M. Allman, V. Paxson and E. Blanton, “TCP Congestion Control,” RFC 5681, IETF, 2009.</a:t>
-            </a:r>
-          </a:p>
-          <a:p>
-            <a:pPr algn="l">
-              <a:spcAft>
-                <a:spcPts val="1000"/>
-              </a:spcAft>
-            </a:pPr>
-            <a:r>
-              <a:rPr sz="1500" b="0">
-                <a:solidFill>
-                  <a:srgbClr val="202020"/>
-                </a:solidFill>
-                <a:latin typeface="Arial"/>
-              </a:rPr>
-              <a:t>[3]</a:t>
-            </a:r>
-            <a:r>
-              <a:rPr sz="1500" b="0">
-                <a:solidFill>
-                  <a:srgbClr val="202020"/>
-                </a:solidFill>
-                <a:latin typeface="Arial"/>
-              </a:rPr>
-              <a:t>  A. Ford et al., “TCP Extensions for Multipath Operation with Multiple Addresses,” RFC 8684, IETF, 2020.</a:t>
-            </a:r>
-          </a:p>
-          <a:p>
-            <a:pPr algn="l">
-              <a:spcAft>
-                <a:spcPts val="1000"/>
-              </a:spcAft>
-            </a:pPr>
-            <a:r>
-              <a:rPr sz="1500" b="0">
-                <a:solidFill>
-                  <a:srgbClr val="202020"/>
-                </a:solidFill>
-                <a:latin typeface="Arial"/>
-              </a:rPr>
-              <a:t>[4]</a:t>
-            </a:r>
-            <a:r>
-              <a:rPr sz="1500" b="0">
-                <a:solidFill>
-                  <a:srgbClr val="202020"/>
-                </a:solidFill>
-                <a:latin typeface="Arial"/>
-              </a:rPr>
-              <a:t>  C. Raiciu et al., “How hard can it be? Designing and implementing a deployable Multipath TCP,” USENIX NSDI, 2012.</a:t>
-            </a:r>
-          </a:p>
-          <a:p>
-            <a:pPr algn="l">
-              <a:spcAft>
-                <a:spcPts val="1000"/>
-              </a:spcAft>
-            </a:pPr>
-            <a:r>
-              <a:rPr sz="1500" b="0">
-                <a:solidFill>
-                  <a:srgbClr val="202020"/>
-                </a:solidFill>
-                <a:latin typeface="Arial"/>
-              </a:rPr>
-              <a:t>[5]</a:t>
-            </a:r>
-            <a:r>
-              <a:rPr sz="1500" b="0">
-                <a:solidFill>
-                  <a:srgbClr val="202020"/>
-                </a:solidFill>
-                <a:latin typeface="Arial"/>
-              </a:rPr>
-              <a:t>  NIST, “Secure Hash Standard (SHS),” FIPS PUB 180-4, 2015.</a:t>
-            </a:r>
-          </a:p>
-        </p:txBody>
-      </p:sp>
-      <p:sp>
-        <p:nvSpPr>
-          <p:cNvPr id="9" name="TextBox 8"/>
+                <a:spcPts val="400"/>
+              </a:spcAft>
+            </a:pPr>
+            <a:r>
+              <a:rPr sz="1100" b="1">
+                <a:solidFill>
+                  <a:srgbClr val="1B6B73"/>
+                </a:solidFill>
+                <a:latin typeface="Arial"/>
+              </a:rPr>
+              <a:t>OUTCOME</a:t>
+            </a:r>
+          </a:p>
+        </p:txBody>
+      </p:sp>
+      <p:sp>
+        <p:nvSpPr>
+          <p:cNvPr id="10" name="TextBox 9"/>
           <p:cNvSpPr txBox="1"/>
           <p:nvPr/>
         </p:nvSpPr>
         <p:spPr>
           <a:xfrm>
-            <a:off x="521207" y="5120640"/>
-            <a:ext cx="8092440" cy="457200"/>
+            <a:off x="704088" y="1664207"/>
+            <a:ext cx="3611879" cy="822959"/>
           </a:xfrm>
           <a:prstGeom prst="rect">
             <a:avLst/>
@@ -9826,89 +9117,733 @@
           <a:p>
             <a:pPr algn="l">
               <a:spcAft>
+                <a:spcPts val="0"/>
+              </a:spcAft>
+            </a:pPr>
+            <a:r>
+              <a:rPr sz="1400" b="0">
+                <a:solidFill>
+                  <a:srgbClr val="202020"/>
+                </a:solidFill>
+                <a:latin typeface="Arial"/>
+              </a:rPr>
+              <a:t>Working multipath transfer with chunk and file verification, failure recovery and resume</a:t>
+            </a:r>
+          </a:p>
+        </p:txBody>
+      </p:sp>
+      <p:sp>
+        <p:nvSpPr>
+          <p:cNvPr id="11" name="Rounded Rectangle 10"/>
+          <p:cNvSpPr/>
+          <p:nvPr/>
+        </p:nvSpPr>
+        <p:spPr>
+          <a:xfrm>
+            <a:off x="4636008" y="1280160"/>
+            <a:ext cx="3977639" cy="1280160"/>
+          </a:xfrm>
+          <a:prstGeom prst="roundRect">
+            <a:avLst>
+              <a:gd name="adj" fmla="val 4000"/>
+            </a:avLst>
+          </a:prstGeom>
+          <a:solidFill>
+            <a:srgbClr val="F1F4F6"/>
+          </a:solidFill>
+          <a:ln>
+            <a:noFill/>
+          </a:ln>
+          <a:effectLst/>
+        </p:spPr>
+        <p:style>
+          <a:lnRef idx="1">
+            <a:schemeClr val="accent1"/>
+          </a:lnRef>
+          <a:fillRef idx="3">
+            <a:schemeClr val="accent1"/>
+          </a:fillRef>
+          <a:effectRef idx="2">
+            <a:schemeClr val="accent1"/>
+          </a:effectRef>
+          <a:fontRef idx="minor">
+            <a:schemeClr val="lt1"/>
+          </a:fontRef>
+        </p:style>
+        <p:txBody>
+          <a:bodyPr rtlCol="0" anchor="ctr"/>
+          <a:lstStyle/>
+          <a:p>
+            <a:pPr algn="ctr"/>
+          </a:p>
+        </p:txBody>
+      </p:sp>
+      <p:sp>
+        <p:nvSpPr>
+          <p:cNvPr id="12" name="TextBox 11"/>
+          <p:cNvSpPr txBox="1"/>
+          <p:nvPr/>
+        </p:nvSpPr>
+        <p:spPr>
+          <a:xfrm>
+            <a:off x="4818888" y="1389888"/>
+            <a:ext cx="3611879" cy="274320"/>
+          </a:xfrm>
+          <a:prstGeom prst="rect">
+            <a:avLst/>
+          </a:prstGeom>
+          <a:noFill/>
+        </p:spPr>
+        <p:txBody>
+          <a:bodyPr wrap="square" lIns="0" rIns="0" tIns="0" bIns="0" anchor="t">
+            <a:spAutoFit/>
+          </a:bodyPr>
+          <a:lstStyle/>
+          <a:p>
+            <a:pPr algn="l">
+              <a:spcAft>
                 <a:spcPts val="400"/>
               </a:spcAft>
             </a:pPr>
             <a:r>
-              <a:rPr sz="1200" b="0">
-                <a:solidFill>
-                  <a:srgbClr val="555555"/>
-                </a:solidFill>
-                <a:latin typeface="Arial"/>
-              </a:rPr>
-              <a:t>Cited on slides 2–3: TCP </a:t>
-            </a:r>
-            <a:r>
-              <a:rPr sz="1200" b="0">
-                <a:solidFill>
-                  <a:srgbClr val="555555"/>
-                </a:solidFill>
-                <a:latin typeface="Arial"/>
-              </a:rPr>
-              <a:t>[1]</a:t>
-            </a:r>
-            <a:r>
-              <a:rPr sz="1200" b="0">
-                <a:solidFill>
-                  <a:srgbClr val="555555"/>
-                </a:solidFill>
-                <a:latin typeface="Arial"/>
-              </a:rPr>
-              <a:t>[2]</a:t>
-            </a:r>
-            <a:r>
-              <a:rPr sz="1200" b="0">
-                <a:solidFill>
-                  <a:srgbClr val="555555"/>
-                </a:solidFill>
-                <a:latin typeface="Arial"/>
-              </a:rPr>
-              <a:t>, multipath background </a:t>
-            </a:r>
-            <a:r>
-              <a:rPr sz="1200" b="0">
-                <a:solidFill>
-                  <a:srgbClr val="555555"/>
-                </a:solidFill>
-                <a:latin typeface="Arial"/>
-              </a:rPr>
-              <a:t>[3]</a:t>
-            </a:r>
-            <a:r>
-              <a:rPr sz="1200" b="0">
-                <a:solidFill>
-                  <a:srgbClr val="555555"/>
-                </a:solidFill>
-                <a:latin typeface="Arial"/>
-              </a:rPr>
-              <a:t>[4]</a:t>
-            </a:r>
-            <a:r>
-              <a:rPr sz="1200" b="0">
-                <a:solidFill>
-                  <a:srgbClr val="555555"/>
-                </a:solidFill>
-                <a:latin typeface="Arial"/>
-              </a:rPr>
-              <a:t>, SHA-256 </a:t>
-            </a:r>
-            <a:r>
-              <a:rPr sz="1200" b="0">
-                <a:solidFill>
-                  <a:srgbClr val="555555"/>
-                </a:solidFill>
-                <a:latin typeface="Arial"/>
-              </a:rPr>
-              <a:t>[5]</a:t>
-            </a:r>
-            <a:r>
-              <a:rPr sz="1200" b="0">
-                <a:solidFill>
-                  <a:srgbClr val="555555"/>
-                </a:solidFill>
-                <a:latin typeface="Arial"/>
-              </a:rPr>
-              <a:t>.</a:t>
+              <a:rPr sz="1100" b="1">
+                <a:solidFill>
+                  <a:srgbClr val="1B6B73"/>
+                </a:solidFill>
+                <a:latin typeface="Arial"/>
+              </a:rPr>
+              <a:t>APPLICATION</a:t>
+            </a:r>
+          </a:p>
+        </p:txBody>
+      </p:sp>
+      <p:sp>
+        <p:nvSpPr>
+          <p:cNvPr id="13" name="TextBox 12"/>
+          <p:cNvSpPr txBox="1"/>
+          <p:nvPr/>
+        </p:nvSpPr>
+        <p:spPr>
+          <a:xfrm>
+            <a:off x="4818888" y="1664207"/>
+            <a:ext cx="3611879" cy="822959"/>
+          </a:xfrm>
+          <a:prstGeom prst="rect">
+            <a:avLst/>
+          </a:prstGeom>
+          <a:noFill/>
+        </p:spPr>
+        <p:txBody>
+          <a:bodyPr wrap="square" lIns="0" rIns="0" tIns="0" bIns="0" anchor="t">
+            <a:spAutoFit/>
+          </a:bodyPr>
+          <a:lstStyle/>
+          <a:p>
+            <a:pPr algn="l">
+              <a:spcAft>
+                <a:spcPts val="0"/>
+              </a:spcAft>
+            </a:pPr>
+            <a:r>
+              <a:rPr sz="1400" b="0">
+                <a:solidFill>
+                  <a:srgbClr val="202020"/>
+                </a:solidFill>
+                <a:latin typeface="Arial"/>
+              </a:rPr>
+              <a:t>Large files over several links (Wi-Fi plus Ethernet, LAN plus VPN)</a:t>
+            </a:r>
+          </a:p>
+        </p:txBody>
+      </p:sp>
+      <p:sp>
+        <p:nvSpPr>
+          <p:cNvPr id="14" name="Rounded Rectangle 13"/>
+          <p:cNvSpPr/>
+          <p:nvPr/>
+        </p:nvSpPr>
+        <p:spPr>
+          <a:xfrm>
+            <a:off x="521207" y="2651760"/>
+            <a:ext cx="3977639" cy="1280160"/>
+          </a:xfrm>
+          <a:prstGeom prst="roundRect">
+            <a:avLst>
+              <a:gd name="adj" fmla="val 4000"/>
+            </a:avLst>
+          </a:prstGeom>
+          <a:solidFill>
+            <a:srgbClr val="F1F4F6"/>
+          </a:solidFill>
+          <a:ln>
+            <a:noFill/>
+          </a:ln>
+          <a:effectLst/>
+        </p:spPr>
+        <p:style>
+          <a:lnRef idx="1">
+            <a:schemeClr val="accent1"/>
+          </a:lnRef>
+          <a:fillRef idx="3">
+            <a:schemeClr val="accent1"/>
+          </a:fillRef>
+          <a:effectRef idx="2">
+            <a:schemeClr val="accent1"/>
+          </a:effectRef>
+          <a:fontRef idx="minor">
+            <a:schemeClr val="lt1"/>
+          </a:fontRef>
+        </p:style>
+        <p:txBody>
+          <a:bodyPr rtlCol="0" anchor="ctr"/>
+          <a:lstStyle/>
+          <a:p>
+            <a:pPr algn="ctr"/>
+          </a:p>
+        </p:txBody>
+      </p:sp>
+      <p:sp>
+        <p:nvSpPr>
+          <p:cNvPr id="15" name="TextBox 14"/>
+          <p:cNvSpPr txBox="1"/>
+          <p:nvPr/>
+        </p:nvSpPr>
+        <p:spPr>
+          <a:xfrm>
+            <a:off x="704088" y="2761488"/>
+            <a:ext cx="3611879" cy="274320"/>
+          </a:xfrm>
+          <a:prstGeom prst="rect">
+            <a:avLst/>
+          </a:prstGeom>
+          <a:noFill/>
+        </p:spPr>
+        <p:txBody>
+          <a:bodyPr wrap="square" lIns="0" rIns="0" tIns="0" bIns="0" anchor="t">
+            <a:spAutoFit/>
+          </a:bodyPr>
+          <a:lstStyle/>
+          <a:p>
+            <a:pPr algn="l">
+              <a:spcAft>
+                <a:spcPts val="400"/>
+              </a:spcAft>
+            </a:pPr>
+            <a:r>
+              <a:rPr sz="1100" b="1">
+                <a:solidFill>
+                  <a:srgbClr val="1B6B73"/>
+                </a:solidFill>
+                <a:latin typeface="Arial"/>
+              </a:rPr>
+              <a:t>LIMITATION</a:t>
+            </a:r>
+          </a:p>
+        </p:txBody>
+      </p:sp>
+      <p:sp>
+        <p:nvSpPr>
+          <p:cNvPr id="16" name="TextBox 15"/>
+          <p:cNvSpPr txBox="1"/>
+          <p:nvPr/>
+        </p:nvSpPr>
+        <p:spPr>
+          <a:xfrm>
+            <a:off x="704088" y="3035808"/>
+            <a:ext cx="3611879" cy="822959"/>
+          </a:xfrm>
+          <a:prstGeom prst="rect">
+            <a:avLst/>
+          </a:prstGeom>
+          <a:noFill/>
+        </p:spPr>
+        <p:txBody>
+          <a:bodyPr wrap="square" lIns="0" rIns="0" tIns="0" bIns="0" anchor="t">
+            <a:spAutoFit/>
+          </a:bodyPr>
+          <a:lstStyle/>
+          <a:p>
+            <a:pPr algn="l">
+              <a:spcAft>
+                <a:spcPts val="0"/>
+              </a:spcAft>
+            </a:pPr>
+            <a:r>
+              <a:rPr sz="1400" b="0">
+                <a:solidFill>
+                  <a:srgbClr val="202020"/>
+                </a:solidFill>
+                <a:latin typeface="Arial"/>
+              </a:rPr>
+              <a:t>One chunk in flight per path; tested on emulated paths on one machine only</a:t>
+            </a:r>
+          </a:p>
+        </p:txBody>
+      </p:sp>
+      <p:sp>
+        <p:nvSpPr>
+          <p:cNvPr id="17" name="Rounded Rectangle 16"/>
+          <p:cNvSpPr/>
+          <p:nvPr/>
+        </p:nvSpPr>
+        <p:spPr>
+          <a:xfrm>
+            <a:off x="4636008" y="2651760"/>
+            <a:ext cx="3977639" cy="1280160"/>
+          </a:xfrm>
+          <a:prstGeom prst="roundRect">
+            <a:avLst>
+              <a:gd name="adj" fmla="val 4000"/>
+            </a:avLst>
+          </a:prstGeom>
+          <a:solidFill>
+            <a:srgbClr val="F1F4F6"/>
+          </a:solidFill>
+          <a:ln>
+            <a:noFill/>
+          </a:ln>
+          <a:effectLst/>
+        </p:spPr>
+        <p:style>
+          <a:lnRef idx="1">
+            <a:schemeClr val="accent1"/>
+          </a:lnRef>
+          <a:fillRef idx="3">
+            <a:schemeClr val="accent1"/>
+          </a:fillRef>
+          <a:effectRef idx="2">
+            <a:schemeClr val="accent1"/>
+          </a:effectRef>
+          <a:fontRef idx="minor">
+            <a:schemeClr val="lt1"/>
+          </a:fontRef>
+        </p:style>
+        <p:txBody>
+          <a:bodyPr rtlCol="0" anchor="ctr"/>
+          <a:lstStyle/>
+          <a:p>
+            <a:pPr algn="ctr"/>
+          </a:p>
+        </p:txBody>
+      </p:sp>
+      <p:sp>
+        <p:nvSpPr>
+          <p:cNvPr id="18" name="TextBox 17"/>
+          <p:cNvSpPr txBox="1"/>
+          <p:nvPr/>
+        </p:nvSpPr>
+        <p:spPr>
+          <a:xfrm>
+            <a:off x="4818888" y="2761488"/>
+            <a:ext cx="3611879" cy="274320"/>
+          </a:xfrm>
+          <a:prstGeom prst="rect">
+            <a:avLst/>
+          </a:prstGeom>
+          <a:noFill/>
+        </p:spPr>
+        <p:txBody>
+          <a:bodyPr wrap="square" lIns="0" rIns="0" tIns="0" bIns="0" anchor="t">
+            <a:spAutoFit/>
+          </a:bodyPr>
+          <a:lstStyle/>
+          <a:p>
+            <a:pPr algn="l">
+              <a:spcAft>
+                <a:spcPts val="400"/>
+              </a:spcAft>
+            </a:pPr>
+            <a:r>
+              <a:rPr sz="1100" b="1">
+                <a:solidFill>
+                  <a:srgbClr val="1B6B73"/>
+                </a:solidFill>
+                <a:latin typeface="Arial"/>
+              </a:rPr>
+              <a:t>FUTURE SCOPE</a:t>
+            </a:r>
+          </a:p>
+        </p:txBody>
+      </p:sp>
+      <p:sp>
+        <p:nvSpPr>
+          <p:cNvPr id="19" name="TextBox 18"/>
+          <p:cNvSpPr txBox="1"/>
+          <p:nvPr/>
+        </p:nvSpPr>
+        <p:spPr>
+          <a:xfrm>
+            <a:off x="4818888" y="3035808"/>
+            <a:ext cx="3611879" cy="822959"/>
+          </a:xfrm>
+          <a:prstGeom prst="rect">
+            <a:avLst/>
+          </a:prstGeom>
+          <a:noFill/>
+        </p:spPr>
+        <p:txBody>
+          <a:bodyPr wrap="square" lIns="0" rIns="0" tIns="0" bIns="0" anchor="t">
+            <a:spAutoFit/>
+          </a:bodyPr>
+          <a:lstStyle/>
+          <a:p>
+            <a:pPr algn="l">
+              <a:spcAft>
+                <a:spcPts val="0"/>
+              </a:spcAft>
+            </a:pPr>
+            <a:r>
+              <a:rPr sz="1400" b="0">
+                <a:solidFill>
+                  <a:srgbClr val="202020"/>
+                </a:solidFill>
+                <a:latin typeface="Arial"/>
+              </a:rPr>
+              <a:t>Sliding window per path; real two-machine test with Wireshark captures</a:t>
+            </a:r>
+          </a:p>
+        </p:txBody>
+      </p:sp>
+      <p:sp>
+        <p:nvSpPr>
+          <p:cNvPr id="20" name="Rounded Rectangle 19"/>
+          <p:cNvSpPr/>
+          <p:nvPr/>
+        </p:nvSpPr>
+        <p:spPr>
+          <a:xfrm>
+            <a:off x="521207" y="4114800"/>
+            <a:ext cx="8092440" cy="1280160"/>
+          </a:xfrm>
+          <a:prstGeom prst="roundRect">
+            <a:avLst>
+              <a:gd name="adj" fmla="val 4000"/>
+            </a:avLst>
+          </a:prstGeom>
+          <a:solidFill>
+            <a:srgbClr val="F1F4F6"/>
+          </a:solidFill>
+          <a:ln>
+            <a:noFill/>
+          </a:ln>
+          <a:effectLst/>
+        </p:spPr>
+        <p:style>
+          <a:lnRef idx="1">
+            <a:schemeClr val="accent1"/>
+          </a:lnRef>
+          <a:fillRef idx="3">
+            <a:schemeClr val="accent1"/>
+          </a:fillRef>
+          <a:effectRef idx="2">
+            <a:schemeClr val="accent1"/>
+          </a:effectRef>
+          <a:fontRef idx="minor">
+            <a:schemeClr val="lt1"/>
+          </a:fontRef>
+        </p:style>
+        <p:txBody>
+          <a:bodyPr rtlCol="0" anchor="ctr"/>
+          <a:lstStyle/>
+          <a:p>
+            <a:pPr algn="ctr"/>
+          </a:p>
+        </p:txBody>
+      </p:sp>
+      <p:sp>
+        <p:nvSpPr>
+          <p:cNvPr id="21" name="TextBox 20"/>
+          <p:cNvSpPr txBox="1"/>
+          <p:nvPr/>
+        </p:nvSpPr>
+        <p:spPr>
+          <a:xfrm>
+            <a:off x="731520" y="4206240"/>
+            <a:ext cx="7680960" cy="274320"/>
+          </a:xfrm>
+          <a:prstGeom prst="rect">
+            <a:avLst/>
+          </a:prstGeom>
+          <a:noFill/>
+        </p:spPr>
+        <p:txBody>
+          <a:bodyPr wrap="square" lIns="0" rIns="0" tIns="0" bIns="0" anchor="t">
+            <a:spAutoFit/>
+          </a:bodyPr>
+          <a:lstStyle/>
+          <a:p>
+            <a:pPr algn="l">
+              <a:spcAft>
+                <a:spcPts val="400"/>
+              </a:spcAft>
+            </a:pPr>
+            <a:r>
+              <a:rPr sz="1100" b="1">
+                <a:solidFill>
+                  <a:srgbClr val="1B6B73"/>
+                </a:solidFill>
+                <a:latin typeface="Arial"/>
+              </a:rPr>
+              <a:t>TEAM CONTRIBUTIONS</a:t>
+            </a:r>
+          </a:p>
+        </p:txBody>
+      </p:sp>
+      <p:sp>
+        <p:nvSpPr>
+          <p:cNvPr id="22" name="TextBox 21"/>
+          <p:cNvSpPr txBox="1"/>
+          <p:nvPr/>
+        </p:nvSpPr>
+        <p:spPr>
+          <a:xfrm>
+            <a:off x="731520" y="4526280"/>
+            <a:ext cx="2600000" cy="822960"/>
+          </a:xfrm>
+          <a:prstGeom prst="rect">
+            <a:avLst/>
+          </a:prstGeom>
+          <a:noFill/>
+        </p:spPr>
+        <p:txBody>
+          <a:bodyPr wrap="square" lIns="0" rIns="0" tIns="0" bIns="0" anchor="t">
+            <a:spAutoFit/>
+          </a:bodyPr>
+          <a:lstStyle/>
+          <a:p>
+            <a:pPr algn="l">
+              <a:spcAft>
+                <a:spcPts val="200"/>
+              </a:spcAft>
+            </a:pPr>
+            <a:r>
+              <a:rPr sz="1300" b="1">
+                <a:solidFill>
+                  <a:srgbClr val="202020"/>
+                </a:solidFill>
+                <a:latin typeface="Arial"/>
+              </a:rPr>
+              <a:t>Saksham Singh Sisodiya</a:t>
+            </a:r>
+          </a:p>
+          <a:p>
+            <a:pPr algn="l">
+              <a:spcAft>
+                <a:spcPts val="200"/>
+              </a:spcAft>
+            </a:pPr>
+            <a:r>
+              <a:rPr sz="1300" b="0">
+                <a:solidFill>
+                  <a:srgbClr val="202020"/>
+                </a:solidFill>
+                <a:latin typeface="Arial"/>
+              </a:rPr>
+              <a:t>Protocol, sender, receiver, resume, web UI</a:t>
+            </a:r>
+          </a:p>
+        </p:txBody>
+      </p:sp>
+      <p:sp>
+        <p:nvSpPr>
+          <p:cNvPr id="23" name="TextBox 22"/>
+          <p:cNvSpPr txBox="1"/>
+          <p:nvPr/>
+        </p:nvSpPr>
+        <p:spPr>
+          <a:xfrm>
+            <a:off x="3451520" y="4526280"/>
+            <a:ext cx="2600000" cy="822960"/>
+          </a:xfrm>
+          <a:prstGeom prst="rect">
+            <a:avLst/>
+          </a:prstGeom>
+          <a:noFill/>
+        </p:spPr>
+        <p:txBody>
+          <a:bodyPr wrap="square" lIns="0" rIns="0" tIns="0" bIns="0" anchor="t">
+            <a:spAutoFit/>
+          </a:bodyPr>
+          <a:lstStyle/>
+          <a:p>
+            <a:pPr algn="l">
+              <a:spcAft>
+                <a:spcPts val="200"/>
+              </a:spcAft>
+            </a:pPr>
+            <a:r>
+              <a:rPr sz="1300" b="1">
+                <a:solidFill>
+                  <a:srgbClr val="202020"/>
+                </a:solidFill>
+                <a:latin typeface="Arial"/>
+              </a:rPr>
+              <a:t>Parth Dande</a:t>
+            </a:r>
+          </a:p>
+          <a:p>
+            <a:pPr algn="l">
+              <a:spcAft>
+                <a:spcPts val="200"/>
+              </a:spcAft>
+            </a:pPr>
+            <a:r>
+              <a:rPr sz="1300" b="0">
+                <a:solidFill>
+                  <a:srgbClr val="202020"/>
+                </a:solidFill>
+                <a:latin typeface="Arial"/>
+              </a:rPr>
+              <a:t>Emulator, experiments, presentation</a:t>
+            </a:r>
+          </a:p>
+        </p:txBody>
+      </p:sp>
+      <p:sp>
+        <p:nvSpPr>
+          <p:cNvPr id="23" name="TextBox 22"/>
+          <p:cNvSpPr txBox="1"/>
+          <p:nvPr/>
+        </p:nvSpPr>
+        <p:spPr>
+          <a:xfrm>
+            <a:off x="6171520" y="4526280"/>
+            <a:ext cx="2600000" cy="822960"/>
+          </a:xfrm>
+          <a:prstGeom prst="rect">
+            <a:avLst/>
+          </a:prstGeom>
+          <a:noFill/>
+        </p:spPr>
+        <p:txBody>
+          <a:bodyPr wrap="square" lIns="0" rIns="0" tIns="0" bIns="0" anchor="t">
+            <a:spAutoFit/>
+          </a:bodyPr>
+          <a:lstStyle/>
+          <a:p>
+            <a:pPr algn="l">
+              <a:spcAft>
+                <a:spcPts val="200"/>
+              </a:spcAft>
+            </a:pPr>
+            <a:r>
+              <a:rPr sz="1300" b="1">
+                <a:solidFill>
+                  <a:srgbClr val="202020"/>
+                </a:solidFill>
+                <a:latin typeface="Arial"/>
+              </a:rPr>
+              <a:t>Anupria Gupta</a:t>
+            </a:r>
+          </a:p>
+          <a:p>
+            <a:pPr algn="l">
+              <a:spcAft>
+                <a:spcPts val="200"/>
+              </a:spcAft>
+            </a:pPr>
+            <a:r>
+              <a:rPr sz="1300" b="0">
+                <a:solidFill>
+                  <a:srgbClr val="202020"/>
+                </a:solidFill>
+                <a:latin typeface="Arial"/>
+              </a:rPr>
+              <a:t>Wireshark, dashboard views, test report</a:t>
+            </a:r>
+          </a:p>
+        </p:txBody>
+      </p:sp>
+      <p:sp>
+        <p:nvSpPr>
+          <p:cNvPr id="24" name="Rounded Rectangle 23"/>
+          <p:cNvSpPr/>
+          <p:nvPr/>
+        </p:nvSpPr>
+        <p:spPr>
+          <a:xfrm>
+            <a:off x="521207" y="5532120"/>
+            <a:ext cx="8092440" cy="640080"/>
+          </a:xfrm>
+          <a:prstGeom prst="roundRect">
+            <a:avLst>
+              <a:gd name="adj" fmla="val 4000"/>
+            </a:avLst>
+          </a:prstGeom>
+          <a:solidFill>
+            <a:srgbClr val="F1F4F6"/>
+          </a:solidFill>
+          <a:ln>
+            <a:noFill/>
+          </a:ln>
+          <a:effectLst/>
+        </p:spPr>
+        <p:style>
+          <a:lnRef idx="1">
+            <a:schemeClr val="accent1"/>
+          </a:lnRef>
+          <a:fillRef idx="3">
+            <a:schemeClr val="accent1"/>
+          </a:fillRef>
+          <a:effectRef idx="2">
+            <a:schemeClr val="accent1"/>
+          </a:effectRef>
+          <a:fontRef idx="minor">
+            <a:schemeClr val="lt1"/>
+          </a:fontRef>
+        </p:style>
+        <p:txBody>
+          <a:bodyPr rtlCol="0" anchor="ctr"/>
+          <a:lstStyle/>
+          <a:p>
+            <a:pPr algn="ctr"/>
+          </a:p>
+        </p:txBody>
+      </p:sp>
+      <p:sp>
+        <p:nvSpPr>
+          <p:cNvPr id="25" name="TextBox 24"/>
+          <p:cNvSpPr txBox="1"/>
+          <p:nvPr/>
+        </p:nvSpPr>
+        <p:spPr>
+          <a:xfrm>
+            <a:off x="731520" y="5577840"/>
+            <a:ext cx="7680960" cy="548640"/>
+          </a:xfrm>
+          <a:prstGeom prst="rect">
+            <a:avLst/>
+          </a:prstGeom>
+          <a:noFill/>
+        </p:spPr>
+        <p:txBody>
+          <a:bodyPr wrap="square" lIns="0" rIns="0" tIns="0" bIns="0" anchor="ctr">
+            <a:spAutoFit/>
+          </a:bodyPr>
+          <a:lstStyle/>
+          <a:p>
+            <a:pPr algn="l">
+              <a:spcAft>
+                <a:spcPts val="400"/>
+              </a:spcAft>
+            </a:pPr>
+            <a:r>
+              <a:rPr sz="1250" b="1">
+                <a:solidFill>
+                  <a:srgbClr val="202020"/>
+                </a:solidFill>
+                <a:latin typeface="Arial"/>
+              </a:rPr>
+              <a:t>AI use:</a:t>
+            </a:r>
+            <a:r>
+              <a:rPr sz="1250" b="0">
+                <a:solidFill>
+                  <a:srgbClr val="202020"/>
+                </a:solidFill>
+                <a:latin typeface="Arial"/>
+              </a:rPr>
+              <a:t> Claude Code helped write code, tests and documents; all results come from running the code.</a:t>
             </a:r>
           </a:p>
         </p:txBody>
@@ -9916,7 +9851,7 @@
     </p:spTree>
     <p:extLst>
       <p:ext uri="{BB962C8B-B14F-4D97-AF65-F5344CB8AC3E}">
-        <p14:creationId xmlns:p14="http://schemas.microsoft.com/office/powerpoint/2010/main" val="1399546708"/>
+        <p14:creationId xmlns:p14="http://schemas.microsoft.com/office/powerpoint/2010/main" val="2125721340"/>
       </p:ext>
     </p:extLst>
   </p:cSld>
@@ -9927,21 +9862,36 @@
 </file>
 
 <file path=ppt/slides/slide9.xml><?xml version="1.0" encoding="utf-8"?>
-<p:sld xmlns:a="http://schemas.openxmlformats.org/drawingml/2006/main" xmlns:p="http://schemas.openxmlformats.org/presentationml/2006/main" xmlns:r="http://schemas.openxmlformats.org/officeDocument/2006/relationships">
+<p:sld xmlns:a="http://schemas.openxmlformats.org/drawingml/2006/main" xmlns:r="http://schemas.openxmlformats.org/officeDocument/2006/relationships" xmlns:p="http://schemas.openxmlformats.org/presentationml/2006/main">
   <p:cSld>
+    <p:bg>
+      <p:bgPr>
+        <a:solidFill>
+          <a:srgbClr val="FFFFFF"/>
+        </a:solidFill>
+        <a:effectLst/>
+      </p:bgPr>
+    </p:bg>
     <p:spTree>
       <p:nvGrpSpPr>
         <p:cNvPr id="1" name=""/>
         <p:cNvGrpSpPr/>
         <p:nvPr/>
       </p:nvGrpSpPr>
-      <p:grpSpPr/>
-      <p:sp>
-        <p:nvSpPr>
-          <p:cNvPr id="8" name="Rectangle 7">
+      <p:grpSpPr>
+        <a:xfrm>
+          <a:off x="0" y="0"/>
+          <a:ext cx="0" cy="0"/>
+          <a:chOff x="0" y="0"/>
+          <a:chExt cx="0" cy="0"/>
+        </a:xfrm>
+      </p:grpSpPr>
+      <p:sp>
+        <p:nvSpPr>
+          <p:cNvPr id="6" name="Rectangle 5">
             <a:extLst>
               <a:ext uri="{FF2B5EF4-FFF2-40B4-BE49-F238E27FC236}">
-                <a16:creationId xmlns:a16="http://schemas.microsoft.com/office/drawing/2014/main" id="{3AB6F581-D019-4446-9B09-873266454C32}"/>
+                <a16:creationId xmlns:a16="http://schemas.microsoft.com/office/drawing/2014/main" id="{2B87E46F-E649-4EC2-BE15-E3DC1B512D09}"/>
               </a:ext>
             </a:extLst>
           </p:cNvPr>
@@ -9990,7 +9940,7 @@
               </a:defRPr>
             </a:pPr>
             <a:r>
-              <a:rPr sz="2550" b="1" dirty="0">
+              <a:rPr sz="2550" b="1">
                 <a:solidFill>
                   <a:srgbClr val="20375C"/>
                 </a:solidFill>
@@ -9998,7 +9948,7 @@
                 <a:ea typeface="Arial"/>
                 <a:cs typeface="Arial"/>
               </a:rPr>
-              <a:t>Views and Scenarios</a:t>
+              <a:t>References</a:t>
             </a:r>
           </a:p>
         </p:txBody>
@@ -10008,7 +9958,7 @@
           <p:cNvPr id="2" name="Rectangle 1">
             <a:extLst>
               <a:ext uri="{FF2B5EF4-FFF2-40B4-BE49-F238E27FC236}">
-                <a16:creationId xmlns:a16="http://schemas.microsoft.com/office/drawing/2014/main" id="{D9B7B2C0-778B-420B-9AC8-791FED994D01}"/>
+                <a16:creationId xmlns:a16="http://schemas.microsoft.com/office/drawing/2014/main" id="{D28BC680-DAE1-4C4A-B29D-BFCE9D74EB15}"/>
               </a:ext>
             </a:extLst>
           </p:cNvPr>
@@ -10075,7 +10025,7 @@
           <p:cNvPr id="3" name="Rectangle 2">
             <a:extLst>
               <a:ext uri="{FF2B5EF4-FFF2-40B4-BE49-F238E27FC236}">
-                <a16:creationId xmlns:a16="http://schemas.microsoft.com/office/drawing/2014/main" id="{B5A4A980-7EF8-4344-9A96-EEAF374C7B47}"/>
+                <a16:creationId xmlns:a16="http://schemas.microsoft.com/office/drawing/2014/main" id="{52937739-9035-4330-B6E1-0CD991043B34}"/>
               </a:ext>
             </a:extLst>
           </p:cNvPr>
@@ -10132,102 +10082,215 @@
                 <a:ea typeface="Arial"/>
                 <a:cs typeface="Arial"/>
               </a:rPr>
-              <a:t>35 seconds</a:t>
-            </a:r>
-          </a:p>
-        </p:txBody>
-      </p:sp>
-      <p:pic>
-        <p:nvPicPr>
-          <p:cNvPr id="9" name="Picture 8" descr="scn_sender.png"/>
-          <p:cNvPicPr>
-            <a:picLocks noChangeAspect="1"/>
-          </p:cNvPicPr>
-          <p:nvPr/>
-        </p:nvPicPr>
-        <p:blipFill>
-          <a:blip r:embed="rId2"/>
-          <a:stretch>
-            <a:fillRect/>
-          </a:stretch>
-        </p:blipFill>
-        <p:spPr>
-          <a:xfrm>
-            <a:off x="523875" y="1250000"/>
-            <a:ext cx="4000000" cy="3032258"/>
+              <a:t>Backup slide</a:t>
+            </a:r>
+          </a:p>
+        </p:txBody>
+      </p:sp>
+      <p:sp>
+        <p:nvSpPr>
+          <p:cNvPr id="7" name="Rounded Rectangle 6"/>
+          <p:cNvSpPr/>
+          <p:nvPr/>
+        </p:nvSpPr>
+        <p:spPr>
+          <a:xfrm>
+            <a:off x="521207" y="1325880"/>
+            <a:ext cx="8092440" cy="3566160"/>
+          </a:xfrm>
+          <a:prstGeom prst="roundRect">
+            <a:avLst>
+              <a:gd name="adj" fmla="val 4000"/>
+            </a:avLst>
+          </a:prstGeom>
+          <a:solidFill>
+            <a:srgbClr val="F1F4F6"/>
+          </a:solidFill>
+          <a:ln>
+            <a:noFill/>
+          </a:ln>
+          <a:effectLst/>
+        </p:spPr>
+        <p:style>
+          <a:lnRef idx="1">
+            <a:schemeClr val="accent1"/>
+          </a:lnRef>
+          <a:fillRef idx="3">
+            <a:schemeClr val="accent1"/>
+          </a:fillRef>
+          <a:effectRef idx="2">
+            <a:schemeClr val="accent1"/>
+          </a:effectRef>
+          <a:fontRef idx="minor">
+            <a:schemeClr val="lt1"/>
+          </a:fontRef>
+        </p:style>
+        <p:txBody>
+          <a:bodyPr rtlCol="0" anchor="ctr"/>
+          <a:lstStyle/>
+          <a:p>
+            <a:pPr algn="ctr"/>
+          </a:p>
+        </p:txBody>
+      </p:sp>
+      <p:sp>
+        <p:nvSpPr>
+          <p:cNvPr id="8" name="TextBox 7"/>
+          <p:cNvSpPr txBox="1"/>
+          <p:nvPr/>
+        </p:nvSpPr>
+        <p:spPr>
+          <a:xfrm>
+            <a:off x="777240" y="1554480"/>
+            <a:ext cx="7589520" cy="3200400"/>
           </a:xfrm>
           <a:prstGeom prst="rect">
             <a:avLst/>
           </a:prstGeom>
-        </p:spPr>
-      </p:pic>
-      <p:pic>
-        <p:nvPicPr>
-          <p:cNvPr id="10" name="Picture 9" descr="scn_receiver.png"/>
-          <p:cNvPicPr>
-            <a:picLocks noChangeAspect="1"/>
-          </p:cNvPicPr>
-          <p:nvPr/>
-        </p:nvPicPr>
-        <p:blipFill>
-          <a:blip r:embed="rId3"/>
-          <a:stretch>
-            <a:fillRect/>
-          </a:stretch>
-        </p:blipFill>
-        <p:spPr>
-          <a:xfrm>
-            <a:off x="4673875" y="1250000"/>
-            <a:ext cx="4000000" cy="3032258"/>
-          </a:xfrm>
-          <a:prstGeom prst="rect">
-            <a:avLst/>
-          </a:prstGeom>
-        </p:spPr>
-      </p:pic>
-      <p:sp>
-        <p:nvSpPr>
-          <p:cNvPr id="11" name="TextBox 10"/>
-          <p:cNvSpPr txBox="1"/>
-          <p:nvPr/>
-        </p:nvSpPr>
-        <p:spPr>
-          <a:xfrm>
-            <a:off x="523875" y="4322258"/>
-            <a:ext cx="4000000" cy="300000"/>
-          </a:xfrm>
-          <a:prstGeom prst="rect">
-            <a:avLst/>
-          </a:prstGeom>
           <a:noFill/>
         </p:spPr>
         <p:txBody>
-          <a:bodyPr wrap="square">
+          <a:bodyPr wrap="square" lIns="0" rIns="0" tIns="0" bIns="0" anchor="t">
             <a:spAutoFit/>
           </a:bodyPr>
           <a:lstStyle/>
           <a:p>
-            <a:r>
-              <a:rPr sz="1100" b="1">
-                <a:solidFill>
-                  <a:srgbClr val="16324F"/>
-                </a:solidFill>
-              </a:rPr>
-              <a:t>Sender: Delivered, send another</a:t>
-            </a:r>
-          </a:p>
-        </p:txBody>
-      </p:sp>
-      <p:sp>
-        <p:nvSpPr>
-          <p:cNvPr id="12" name="TextBox 11"/>
+            <a:pPr algn="l">
+              <a:spcAft>
+                <a:spcPts val="1000"/>
+              </a:spcAft>
+            </a:pPr>
+            <a:r>
+              <a:rPr sz="1500" b="0">
+                <a:solidFill>
+                  <a:srgbClr val="202020"/>
+                </a:solidFill>
+                <a:latin typeface="Arial"/>
+              </a:rPr>
+              <a:t>[1]</a:t>
+            </a:r>
+            <a:r>
+              <a:rPr sz="1500" b="0">
+                <a:solidFill>
+                  <a:srgbClr val="202020"/>
+                </a:solidFill>
+                <a:latin typeface="Arial"/>
+              </a:rPr>
+              <a:t>  J. Eddy, “Transmission Control Protocol (TCP),” RFC 9293, IETF, 2022.</a:t>
+            </a:r>
+          </a:p>
+          <a:p>
+            <a:pPr algn="l">
+              <a:spcAft>
+                <a:spcPts val="1000"/>
+              </a:spcAft>
+            </a:pPr>
+            <a:r>
+              <a:rPr sz="1500" b="0">
+                <a:solidFill>
+                  <a:srgbClr val="202020"/>
+                </a:solidFill>
+                <a:latin typeface="Arial"/>
+              </a:rPr>
+              <a:t>[2]</a:t>
+            </a:r>
+            <a:r>
+              <a:rPr sz="1500" b="0">
+                <a:solidFill>
+                  <a:srgbClr val="202020"/>
+                </a:solidFill>
+                <a:latin typeface="Arial"/>
+              </a:rPr>
+              <a:t>  M. Allman, V. Paxson and E. Blanton, “TCP Congestion Control,” RFC 5681, IETF, 2009.</a:t>
+            </a:r>
+          </a:p>
+          <a:p>
+            <a:pPr algn="l">
+              <a:spcAft>
+                <a:spcPts val="1000"/>
+              </a:spcAft>
+            </a:pPr>
+            <a:r>
+              <a:rPr sz="1500" b="0">
+                <a:solidFill>
+                  <a:srgbClr val="202020"/>
+                </a:solidFill>
+                <a:latin typeface="Arial"/>
+              </a:rPr>
+              <a:t>[3]</a:t>
+            </a:r>
+            <a:r>
+              <a:rPr sz="1500" b="0">
+                <a:solidFill>
+                  <a:srgbClr val="202020"/>
+                </a:solidFill>
+                <a:latin typeface="Arial"/>
+              </a:rPr>
+              <a:t>  A. Ford et al., “TCP Extensions for Multipath Operation with Multiple Addresses,” RFC 8684, IETF, 2020.</a:t>
+            </a:r>
+          </a:p>
+          <a:p>
+            <a:pPr algn="l">
+              <a:spcAft>
+                <a:spcPts val="1000"/>
+              </a:spcAft>
+            </a:pPr>
+            <a:r>
+              <a:rPr sz="1500" b="0">
+                <a:solidFill>
+                  <a:srgbClr val="202020"/>
+                </a:solidFill>
+                <a:latin typeface="Arial"/>
+              </a:rPr>
+              <a:t>[4]</a:t>
+            </a:r>
+            <a:r>
+              <a:rPr sz="1500" b="0">
+                <a:solidFill>
+                  <a:srgbClr val="202020"/>
+                </a:solidFill>
+                <a:latin typeface="Arial"/>
+              </a:rPr>
+              <a:t>  C. Raiciu et al., “How hard can it be? Designing and implementing a deployable Multipath TCP,” USENIX NSDI, 2012.</a:t>
+            </a:r>
+          </a:p>
+          <a:p>
+            <a:pPr algn="l">
+              <a:spcAft>
+                <a:spcPts val="1000"/>
+              </a:spcAft>
+            </a:pPr>
+            <a:r>
+              <a:rPr sz="1500" b="0">
+                <a:solidFill>
+                  <a:srgbClr val="202020"/>
+                </a:solidFill>
+                <a:latin typeface="Arial"/>
+              </a:rPr>
+              <a:t>[5]</a:t>
+            </a:r>
+            <a:r>
+              <a:rPr sz="1500" b="0">
+                <a:solidFill>
+                  <a:srgbClr val="202020"/>
+                </a:solidFill>
+                <a:latin typeface="Arial"/>
+              </a:rPr>
+              <a:t>  NIST, “Secure Hash Standard (SHS),” FIPS PUB 180-4, 2015.</a:t>
+            </a:r>
+          </a:p>
+        </p:txBody>
+      </p:sp>
+      <p:sp>
+        <p:nvSpPr>
+          <p:cNvPr id="9" name="TextBox 8"/>
           <p:cNvSpPr txBox="1"/>
           <p:nvPr/>
         </p:nvSpPr>
         <p:spPr>
           <a:xfrm>
-            <a:off x="4673875" y="4322258"/>
-            <a:ext cx="4000000" cy="300000"/>
+            <a:off x="521207" y="5120640"/>
+            <a:ext cx="8092440" cy="457200"/>
           </a:xfrm>
           <a:prstGeom prst="rect">
             <a:avLst/>
@@ -10235,89 +10298,106 @@
           <a:noFill/>
         </p:spPr>
         <p:txBody>
-          <a:bodyPr wrap="square">
+          <a:bodyPr wrap="square" lIns="0" rIns="0" tIns="0" bIns="0" anchor="t">
             <a:spAutoFit/>
           </a:bodyPr>
           <a:lstStyle/>
           <a:p>
-            <a:r>
-              <a:rPr sz="1100" b="1">
-                <a:solidFill>
-                  <a:srgbClr val="16324F"/>
-                </a:solidFill>
-              </a:rPr>
-              <a:t>Receiver: verified, Download</a:t>
-            </a:r>
-          </a:p>
-        </p:txBody>
-      </p:sp>
-      <p:sp>
-        <p:nvSpPr>
-          <p:cNvPr id="13" name="TextBox 12"/>
-          <p:cNvSpPr txBox="1"/>
-          <p:nvPr/>
-        </p:nvSpPr>
-        <p:spPr>
-          <a:xfrm>
-            <a:off x="523875" y="4652258"/>
-            <a:ext cx="8150000" cy="300000"/>
-          </a:xfrm>
-          <a:prstGeom prst="rect">
-            <a:avLst/>
-          </a:prstGeom>
-          <a:noFill/>
-        </p:spPr>
-        <p:txBody>
-          <a:bodyPr wrap="square">
-            <a:spAutoFit/>
-          </a:bodyPr>
-          <a:lstStyle/>
-          <a:p>
-            <a:r>
-              <a:rPr sz="1100" b="0">
-                <a:solidFill>
-                  <a:srgbClr val="16324F"/>
-                </a:solidFill>
-              </a:rPr>
-              <a:t>Eight scenarios: clean, slow, asymmetric, lossy, heavy loss, path failure, path flap, total failure (nothing saved, no download).</a:t>
-            </a:r>
-          </a:p>
-        </p:txBody>
-      </p:sp>
-      <p:sp>
-        <p:nvSpPr>
-          <p:cNvPr id="14" name="TextBox 13"/>
-          <p:cNvSpPr txBox="1"/>
-          <p:nvPr/>
-        </p:nvSpPr>
-        <p:spPr>
-          <a:xfrm>
-            <a:off x="523875" y="5122258"/>
-            <a:ext cx="8150000" cy="300000"/>
-          </a:xfrm>
-          <a:prstGeom prst="rect">
-            <a:avLst/>
-          </a:prstGeom>
-          <a:noFill/>
-        </p:spPr>
-        <p:txBody>
-          <a:bodyPr wrap="square">
-            <a:spAutoFit/>
-          </a:bodyPr>
-          <a:lstStyle/>
-          <a:p>
-            <a:r>
-              <a:rPr sz="1100" b="0">
-                <a:solidFill>
-                  <a:srgbClr val="16324F"/>
-                </a:solidFill>
-              </a:rPr>
-              <a:t>Graphs now use real time: throughput from chunk completions, millisecond axis under 2 s.</a:t>
+            <a:pPr algn="l">
+              <a:spcAft>
+                <a:spcPts val="400"/>
+              </a:spcAft>
+            </a:pPr>
+            <a:r>
+              <a:rPr sz="1200" b="0">
+                <a:solidFill>
+                  <a:srgbClr val="555555"/>
+                </a:solidFill>
+                <a:latin typeface="Arial"/>
+              </a:rPr>
+              <a:t>Cited on slides 2–3: TCP </a:t>
+            </a:r>
+            <a:r>
+              <a:rPr sz="1200" b="0">
+                <a:solidFill>
+                  <a:srgbClr val="555555"/>
+                </a:solidFill>
+                <a:latin typeface="Arial"/>
+              </a:rPr>
+              <a:t>[1]</a:t>
+            </a:r>
+            <a:r>
+              <a:rPr sz="1200" b="0">
+                <a:solidFill>
+                  <a:srgbClr val="555555"/>
+                </a:solidFill>
+                <a:latin typeface="Arial"/>
+              </a:rPr>
+              <a:t>[2]</a:t>
+            </a:r>
+            <a:r>
+              <a:rPr sz="1200" b="0">
+                <a:solidFill>
+                  <a:srgbClr val="555555"/>
+                </a:solidFill>
+                <a:latin typeface="Arial"/>
+              </a:rPr>
+              <a:t>, multipath background </a:t>
+            </a:r>
+            <a:r>
+              <a:rPr sz="1200" b="0">
+                <a:solidFill>
+                  <a:srgbClr val="555555"/>
+                </a:solidFill>
+                <a:latin typeface="Arial"/>
+              </a:rPr>
+              <a:t>[3]</a:t>
+            </a:r>
+            <a:r>
+              <a:rPr sz="1200" b="0">
+                <a:solidFill>
+                  <a:srgbClr val="555555"/>
+                </a:solidFill>
+                <a:latin typeface="Arial"/>
+              </a:rPr>
+              <a:t>[4]</a:t>
+            </a:r>
+            <a:r>
+              <a:rPr sz="1200" b="0">
+                <a:solidFill>
+                  <a:srgbClr val="555555"/>
+                </a:solidFill>
+                <a:latin typeface="Arial"/>
+              </a:rPr>
+              <a:t>, SHA-256 </a:t>
+            </a:r>
+            <a:r>
+              <a:rPr sz="1200" b="0">
+                <a:solidFill>
+                  <a:srgbClr val="555555"/>
+                </a:solidFill>
+                <a:latin typeface="Arial"/>
+              </a:rPr>
+              <a:t>[5]</a:t>
+            </a:r>
+            <a:r>
+              <a:rPr sz="1200" b="0">
+                <a:solidFill>
+                  <a:srgbClr val="555555"/>
+                </a:solidFill>
+                <a:latin typeface="Arial"/>
+              </a:rPr>
+              <a:t>.</a:t>
             </a:r>
           </a:p>
         </p:txBody>
       </p:sp>
     </p:spTree>
+    <p:extLst>
+      <p:ext uri="{BB962C8B-B14F-4D97-AF65-F5344CB8AC3E}">
+        <p14:creationId xmlns:p14="http://schemas.microsoft.com/office/powerpoint/2010/main" val="1399546708"/>
+      </p:ext>
+    </p:extLst>
   </p:cSld>
   <p:clrMapOvr>
     <a:masterClrMapping/>

</xml_diff>